<commit_message>
Build up significance tests in Week 10 notes; revise Lecture 22 notation
Rewrite the Week 10 notes page for Lecture 22: the logic of a significance
test built from the binomial, sampling distributions, the CLT and z-scores,
with a taste-test walk-through, a notation table, a midterm polling example,
the coin-flip study, significance vs importance and the five steps. Enable
the Week 10 notes menu entry.

Revise the Lecture 22 slides to use the 2024 notes' notation (theta-naught,
p0/mu0, upper/lower-tailed, z_obs, P(Z >= z_obs | H0 true)), replace the
octopus example with a taste test, and turn the tails slide into the poll.

Co-Authored-By: Claude Opus 5.5 (1M context) <noreply@anthropic.com>
</commit_message>
<xml_diff>
--- a/docs/lecture_slides/Week 10/2026/Week10_Lecture22_Slides_10_26_2026.pptx
+++ b/docs/lecture_slides/Week 10/2026/Week10_Lecture22_Slides_10_26_2026.pptx
@@ -4010,7 +4010,7 @@
     </p:spTree>
     <p:extLst>
       <p:ext uri="{BB962C8B-B14F-4D97-AF65-F5344CB8AC3E}">
-        <p14:creationId xmlns:p14="http://schemas.microsoft.com/office/powerpoint/2010/main" val="332857856"/>
+        <p14:creationId xmlns:p14="http://schemas.microsoft.com/office/powerpoint/2010/main" val="2408036258"/>
       </p:ext>
     </p:extLst>
   </p:cSld>
@@ -5012,7 +5012,7 @@
     </p:spTree>
     <p:extLst>
       <p:ext uri="{BB962C8B-B14F-4D97-AF65-F5344CB8AC3E}">
-        <p14:creationId xmlns:p14="http://schemas.microsoft.com/office/powerpoint/2010/main" val="3988451518"/>
+        <p14:creationId xmlns:p14="http://schemas.microsoft.com/office/powerpoint/2010/main" val="3007873360"/>
       </p:ext>
     </p:extLst>
   </p:cSld>
@@ -5700,7 +5700,7 @@
     </p:spTree>
     <p:extLst>
       <p:ext uri="{BB962C8B-B14F-4D97-AF65-F5344CB8AC3E}">
-        <p14:creationId xmlns:p14="http://schemas.microsoft.com/office/powerpoint/2010/main" val="1875864399"/>
+        <p14:creationId xmlns:p14="http://schemas.microsoft.com/office/powerpoint/2010/main" val="3372870117"/>
       </p:ext>
     </p:extLst>
   </p:cSld>
@@ -6713,7 +6713,7 @@
     </p:spTree>
     <p:extLst>
       <p:ext uri="{BB962C8B-B14F-4D97-AF65-F5344CB8AC3E}">
-        <p14:creationId xmlns:p14="http://schemas.microsoft.com/office/powerpoint/2010/main" val="261816030"/>
+        <p14:creationId xmlns:p14="http://schemas.microsoft.com/office/powerpoint/2010/main" val="94102795"/>
       </p:ext>
     </p:extLst>
   </p:cSld>
@@ -6964,105 +6964,6 @@
         <p:spPr>
           <a:xfrm>
             <a:off x="762000" y="1879600"/>
-            <a:ext cx="10668000" cy="381000"/>
-          </a:xfrm>
-          <a:prstGeom prst="rect">
-            <a:avLst/>
-          </a:prstGeom>
-          <a:noFill/>
-        </p:spPr>
-        <p:txBody>
-          <a:bodyPr vert="horz" wrap="square" rtlCol="0">
-            <a:spAutoFit/>
-          </a:bodyPr>
-          <a:lstStyle/>
-          <a:p>
-            <a:pPr>
-              <a:spcAft>
-                <a:spcPts val="200"/>
-              </a:spcAft>
-            </a:pPr>
-            <a:r>
-              <a:rPr lang="en-US">
-                <a:solidFill>
-                  <a:srgbClr val="000000"/>
-                </a:solidFill>
-                <a:latin typeface="Calibri" panose="020F0502020204030204" pitchFamily="34" charset="0"/>
-              </a:rPr>
-              <a:t>If H</a:t>
-            </a:r>
-            <a:r>
-              <a:rPr lang="en-US" baseline="-25000">
-                <a:solidFill>
-                  <a:srgbClr val="000000"/>
-                </a:solidFill>
-                <a:latin typeface="Calibri" panose="020F0502020204030204" pitchFamily="34" charset="0"/>
-              </a:rPr>
-              <a:t>0</a:t>
-            </a:r>
-            <a:r>
-              <a:rPr lang="en-US">
-                <a:solidFill>
-                  <a:srgbClr val="000000"/>
-                </a:solidFill>
-                <a:latin typeface="Calibri" panose="020F0502020204030204" pitchFamily="34" charset="0"/>
-              </a:rPr>
-              <a:t> is true, z</a:t>
-            </a:r>
-            <a:r>
-              <a:rPr lang="en-US" baseline="-25000">
-                <a:solidFill>
-                  <a:srgbClr val="000000"/>
-                </a:solidFill>
-                <a:latin typeface="Calibri" panose="020F0502020204030204" pitchFamily="34" charset="0"/>
-              </a:rPr>
-              <a:t>obs</a:t>
-            </a:r>
-            <a:r>
-              <a:rPr lang="en-US">
-                <a:solidFill>
-                  <a:srgbClr val="000000"/>
-                </a:solidFill>
-                <a:latin typeface="Calibri" panose="020F0502020204030204" pitchFamily="34" charset="0"/>
-              </a:rPr>
-              <a:t> comes from N(0, 1).  Each curve marks a z</a:t>
-            </a:r>
-            <a:r>
-              <a:rPr lang="en-US" baseline="-25000">
-                <a:solidFill>
-                  <a:srgbClr val="000000"/>
-                </a:solidFill>
-                <a:latin typeface="Calibri" panose="020F0502020204030204" pitchFamily="34" charset="0"/>
-              </a:rPr>
-              <a:t>obs</a:t>
-            </a:r>
-            <a:r>
-              <a:rPr lang="en-US">
-                <a:solidFill>
-                  <a:srgbClr val="000000"/>
-                </a:solidFill>
-                <a:latin typeface="Calibri" panose="020F0502020204030204" pitchFamily="34" charset="0"/>
-              </a:rPr>
-              <a:t>;  the shaded area is the P-value.</a:t>
-            </a:r>
-          </a:p>
-        </p:txBody>
-      </p:sp>
-      <p:sp>
-        <p:nvSpPr>
-          <p:cNvPr id="10" name="Question">
-            <a:extLst>
-              <a:ext uri="{FF2B5EF4-FFF2-40B4-BE49-F238E27FC236}">
-                <a16:creationId xmlns:a16="http://schemas.microsoft.com/office/drawing/2014/main" id="{B31E395F-B84E-D1E9-D22A-222467FC4105}"/>
-              </a:ext>
-            </a:extLst>
-          </p:cNvPr>
-          <p:cNvSpPr txBox="1"/>
-          <p:nvPr/>
-        </p:nvSpPr>
-        <p:spPr>
-          <a:xfrm>
-            <a:off x="762000" y="2286000"/>
             <a:ext cx="10668000" cy="369332"/>
           </a:xfrm>
           <a:prstGeom prst="rect">
@@ -7082,13 +6983,130 @@
               </a:spcAft>
             </a:pPr>
             <a:r>
+              <a:rPr lang="en-US">
+                <a:solidFill>
+                  <a:srgbClr val="000000"/>
+                </a:solidFill>
+                <a:latin typeface="Calibri" panose="020F0502020204030204" pitchFamily="34" charset="0"/>
+              </a:rPr>
+              <a:t>Polls put Candidate X at 52%.  Our poll of 1,000 likely voters finds 49.0%, so testing H</a:t>
+            </a:r>
+            <a:r>
+              <a:rPr lang="en-US" baseline="-25000">
+                <a:solidFill>
+                  <a:srgbClr val="000000"/>
+                </a:solidFill>
+                <a:latin typeface="Calibri" panose="020F0502020204030204" pitchFamily="34" charset="0"/>
+              </a:rPr>
+              <a:t>0</a:t>
+            </a:r>
+            <a:r>
+              <a:rPr lang="en-US">
+                <a:solidFill>
+                  <a:srgbClr val="000000"/>
+                </a:solidFill>
+                <a:latin typeface="Calibri" panose="020F0502020204030204" pitchFamily="34" charset="0"/>
+              </a:rPr>
+              <a:t>: p = 0.52 gives z</a:t>
+            </a:r>
+            <a:r>
+              <a:rPr lang="en-US" baseline="-25000">
+                <a:solidFill>
+                  <a:srgbClr val="000000"/>
+                </a:solidFill>
+                <a:latin typeface="Calibri" panose="020F0502020204030204" pitchFamily="34" charset="0"/>
+              </a:rPr>
+              <a:t>obs</a:t>
+            </a:r>
+            <a:r>
+              <a:rPr lang="en-US">
+                <a:solidFill>
+                  <a:srgbClr val="000000"/>
+                </a:solidFill>
+                <a:latin typeface="Calibri" panose="020F0502020204030204" pitchFamily="34" charset="0"/>
+              </a:rPr>
+              <a:t> = −1.90.</a:t>
+            </a:r>
+          </a:p>
+        </p:txBody>
+      </p:sp>
+      <p:sp>
+        <p:nvSpPr>
+          <p:cNvPr id="10" name="Question">
+            <a:extLst>
+              <a:ext uri="{FF2B5EF4-FFF2-40B4-BE49-F238E27FC236}">
+                <a16:creationId xmlns:a16="http://schemas.microsoft.com/office/drawing/2014/main" id="{B31E395F-B84E-D1E9-D22A-222467FC4105}"/>
+              </a:ext>
+            </a:extLst>
+          </p:cNvPr>
+          <p:cNvSpPr txBox="1"/>
+          <p:nvPr/>
+        </p:nvSpPr>
+        <p:spPr>
+          <a:xfrm>
+            <a:off x="762000" y="2274332"/>
+            <a:ext cx="10668000" cy="369332"/>
+          </a:xfrm>
+          <a:prstGeom prst="rect">
+            <a:avLst/>
+          </a:prstGeom>
+          <a:noFill/>
+        </p:spPr>
+        <p:txBody>
+          <a:bodyPr vert="horz" wrap="square" rtlCol="0">
+            <a:spAutoFit/>
+          </a:bodyPr>
+          <a:lstStyle/>
+          <a:p>
+            <a:pPr>
+              <a:spcAft>
+                <a:spcPts val="200"/>
+              </a:spcAft>
+            </a:pPr>
+            <a:r>
               <a:rPr lang="en-US" b="1">
                 <a:solidFill>
                   <a:srgbClr val="C00000"/>
                 </a:solidFill>
                 <a:latin typeface="Calibri" panose="020F0502020204030204" pitchFamily="34" charset="0"/>
               </a:rPr>
-              <a:t>What is each P-value?  Which are significant at α = 0.05?</a:t>
+              <a:t>What is the P-value under each H</a:t>
+            </a:r>
+            <a:r>
+              <a:rPr lang="en-US" b="1" baseline="-25000">
+                <a:solidFill>
+                  <a:srgbClr val="C00000"/>
+                </a:solidFill>
+                <a:latin typeface="Calibri" panose="020F0502020204030204" pitchFamily="34" charset="0"/>
+              </a:rPr>
+              <a:t>A</a:t>
+            </a:r>
+            <a:r>
+              <a:rPr lang="en-US" b="1">
+                <a:solidFill>
+                  <a:srgbClr val="C00000"/>
+                </a:solidFill>
+                <a:latin typeface="Calibri" panose="020F0502020204030204" pitchFamily="34" charset="0"/>
+              </a:rPr>
+              <a:t>?  Which ones reject H</a:t>
+            </a:r>
+            <a:r>
+              <a:rPr lang="en-US" b="1" baseline="-25000">
+                <a:solidFill>
+                  <a:srgbClr val="C00000"/>
+                </a:solidFill>
+                <a:latin typeface="Calibri" panose="020F0502020204030204" pitchFamily="34" charset="0"/>
+              </a:rPr>
+              <a:t>0</a:t>
+            </a:r>
+            <a:r>
+              <a:rPr lang="en-US" b="1">
+                <a:solidFill>
+                  <a:srgbClr val="C00000"/>
+                </a:solidFill>
+                <a:latin typeface="Calibri" panose="020F0502020204030204" pitchFamily="34" charset="0"/>
+              </a:rPr>
+              <a:t> at α = 0.05?</a:t>
             </a:r>
           </a:p>
         </p:txBody>
@@ -7107,7 +7125,7 @@
         </p:nvSpPr>
         <p:spPr>
           <a:xfrm>
-            <a:off x="762000" y="5296932"/>
+            <a:off x="762000" y="5285264"/>
             <a:ext cx="10668000" cy="774700"/>
           </a:xfrm>
           <a:prstGeom prst="roundRect">
@@ -7153,7 +7171,7 @@
                 </a:solidFill>
                 <a:latin typeface="Calibri" panose="020F0502020204030204" pitchFamily="34" charset="0"/>
               </a:rPr>
-              <a:t>upper:  P(Z ≥ 1.80) = 0.036      lower:  P(Z ≤ −1.80) = 0.036      two:  2 × 0.036 = 0.072</a:t>
+              <a:t>upper:  P(Z ≥ −1.90) = 0.971      lower:  P(Z ≤ −1.90) = 0.029      two:  2 × 0.029 = 0.057</a:t>
             </a:r>
           </a:p>
           <a:p>
@@ -7164,17 +7182,53 @@
                 </a:solidFill>
                 <a:latin typeface="Calibri" panose="020F0502020204030204" pitchFamily="34" charset="0"/>
               </a:rPr>
-              <a:t>Significant for the one-sided tests, not the two-sided one:  0.072 ≥ 0.05</a:t>
+              <a:t>Only the lower-tailed test rejects H</a:t>
+            </a:r>
+            <a:r>
+              <a:rPr lang="en-US" sz="2000" b="1" baseline="-25000">
+                <a:solidFill>
+                  <a:srgbClr val="C00000"/>
+                </a:solidFill>
+                <a:latin typeface="Calibri" panose="020F0502020204030204" pitchFamily="34" charset="0"/>
+              </a:rPr>
+              <a:t>0</a:t>
+            </a:r>
+            <a:r>
+              <a:rPr lang="en-US" sz="2000" b="1">
+                <a:solidFill>
+                  <a:srgbClr val="C00000"/>
+                </a:solidFill>
+                <a:latin typeface="Calibri" panose="020F0502020204030204" pitchFamily="34" charset="0"/>
+              </a:rPr>
+              <a:t>:  H</a:t>
+            </a:r>
+            <a:r>
+              <a:rPr lang="en-US" sz="2000" b="1" baseline="-25000">
+                <a:solidFill>
+                  <a:srgbClr val="C00000"/>
+                </a:solidFill>
+                <a:latin typeface="Calibri" panose="020F0502020204030204" pitchFamily="34" charset="0"/>
+              </a:rPr>
+              <a:t>A</a:t>
+            </a:r>
+            <a:r>
+              <a:rPr lang="en-US" sz="2000" b="1">
+                <a:solidFill>
+                  <a:srgbClr val="C00000"/>
+                </a:solidFill>
+                <a:latin typeface="Calibri" panose="020F0502020204030204" pitchFamily="34" charset="0"/>
+              </a:rPr>
+              <a:t> must be set before seeing the data</a:t>
             </a:r>
           </a:p>
         </p:txBody>
       </p:sp>
       <p:pic>
         <p:nvPicPr>
-          <p:cNvPr id="6" name="l22_tails.png" descr="Three standard normal curves. Left, for the alternative p greater than p0: z = 1.80 marked, upper tail shaded. Middle, p less than p0: z = -1.80 marked, lower tail shaded. Right, p not equal to p0: both -1.80 and 1.80 marked, both tails shaded.">
-            <a:extLst>
-              <a:ext uri="{FF2B5EF4-FFF2-40B4-BE49-F238E27FC236}">
-                <a16:creationId xmlns:a16="http://schemas.microsoft.com/office/drawing/2014/main" id="{8C34C4C7-6C4B-EC25-75AC-97C7FFD719A1}"/>
+          <p:cNvPr id="6" name="l22_tails.png" descr="Three standard normal curves, each with the poll z observed of -1.90 marked. Left, for the alternative p greater than 0.52: everything above -1.90 is shaded, almost the whole curve. Middle, p less than 0.52: the small lower tail below -1.90 is shaded. Right, p not equal to 0.52: both tails beyond -1.90 and 1.90 are shaded.">
+            <a:extLst>
+              <a:ext uri="{FF2B5EF4-FFF2-40B4-BE49-F238E27FC236}">
+                <a16:creationId xmlns:a16="http://schemas.microsoft.com/office/drawing/2014/main" id="{86ACFF03-76A9-D68A-F87A-420449EBAC2B}"/>
               </a:ext>
             </a:extLst>
           </p:cNvPr>
@@ -7197,7 +7251,7 @@
         </p:blipFill>
         <p:spPr>
           <a:xfrm>
-            <a:off x="762000" y="2706132"/>
+            <a:off x="762000" y="2694464"/>
             <a:ext cx="10668000" cy="2540000"/>
           </a:xfrm>
           <a:prstGeom prst="rect">
@@ -7208,7 +7262,7 @@
     </p:spTree>
     <p:extLst>
       <p:ext uri="{BB962C8B-B14F-4D97-AF65-F5344CB8AC3E}">
-        <p14:creationId xmlns:p14="http://schemas.microsoft.com/office/powerpoint/2010/main" val="2805909233"/>
+        <p14:creationId xmlns:p14="http://schemas.microsoft.com/office/powerpoint/2010/main" val="802648944"/>
       </p:ext>
     </p:extLst>
   </p:cSld>
@@ -7594,7 +7648,7 @@
           <p:nvPr>
             <p:extLst>
               <p:ext uri="{D42A27DB-BD31-4B8C-83A1-F6EECF244321}">
-                <p14:modId xmlns:p14="http://schemas.microsoft.com/office/powerpoint/2010/main" val="2842829003"/>
+                <p14:modId xmlns:p14="http://schemas.microsoft.com/office/powerpoint/2010/main" val="1258285308"/>
               </p:ext>
             </p:extLst>
           </p:nvPr>
@@ -7827,7 +7881,7 @@
     </p:spTree>
     <p:extLst>
       <p:ext uri="{BB962C8B-B14F-4D97-AF65-F5344CB8AC3E}">
-        <p14:creationId xmlns:p14="http://schemas.microsoft.com/office/powerpoint/2010/main" val="1766470048"/>
+        <p14:creationId xmlns:p14="http://schemas.microsoft.com/office/powerpoint/2010/main" val="480451647"/>
       </p:ext>
     </p:extLst>
   </p:cSld>
@@ -8451,7 +8505,7 @@
     </p:spTree>
     <p:extLst>
       <p:ext uri="{BB962C8B-B14F-4D97-AF65-F5344CB8AC3E}">
-        <p14:creationId xmlns:p14="http://schemas.microsoft.com/office/powerpoint/2010/main" val="2676468317"/>
+        <p14:creationId xmlns:p14="http://schemas.microsoft.com/office/powerpoint/2010/main" val="126512286"/>
       </p:ext>
     </p:extLst>
   </p:cSld>
@@ -13730,7 +13784,7 @@
     </p:spTree>
     <p:extLst>
       <p:ext uri="{BB962C8B-B14F-4D97-AF65-F5344CB8AC3E}">
-        <p14:creationId xmlns:p14="http://schemas.microsoft.com/office/powerpoint/2010/main" val="884053825"/>
+        <p14:creationId xmlns:p14="http://schemas.microsoft.com/office/powerpoint/2010/main" val="1726921116"/>
       </p:ext>
     </p:extLst>
   </p:cSld>
@@ -14223,7 +14277,7 @@
     </p:spTree>
     <p:extLst>
       <p:ext uri="{BB962C8B-B14F-4D97-AF65-F5344CB8AC3E}">
-        <p14:creationId xmlns:p14="http://schemas.microsoft.com/office/powerpoint/2010/main" val="708044290"/>
+        <p14:creationId xmlns:p14="http://schemas.microsoft.com/office/powerpoint/2010/main" val="4264443962"/>
       </p:ext>
     </p:extLst>
   </p:cSld>
@@ -14794,7 +14848,7 @@
     </p:spTree>
     <p:extLst>
       <p:ext uri="{BB962C8B-B14F-4D97-AF65-F5344CB8AC3E}">
-        <p14:creationId xmlns:p14="http://schemas.microsoft.com/office/powerpoint/2010/main" val="1927341877"/>
+        <p14:creationId xmlns:p14="http://schemas.microsoft.com/office/powerpoint/2010/main" val="3884269920"/>
       </p:ext>
     </p:extLst>
   </p:cSld>

</xml_diff>